<commit_message>
feat(data): integrate empirical transit dataset and benchmark pipeline
- Add data/load_real_data.py adapter to parse ISCON-PDPU bus corridor trips`n- Extract corridor stops, directions, arrival times, and ETA feature targets`n- Update run_experiment.py with --dataset {real, synthetic} support (default: real)`n- Add reference paper text and PDF documentation`n- Rebuild presentation deck with real-world validation results`n- Update .gitignore for raw dataset and CSV artifacts
</commit_message>
<xml_diff>
--- a/presentation/Guideline_Layer_PoC.pptx
+++ b/presentation/Guideline_Layer_PoC.pptx
@@ -5327,7 +5327,7 @@
                           </a:solidFill>
                           <a:latin typeface="Calibri"/>
                         </a:rPr>
-                        <a:t>1.3</a:t>
+                        <a:t>0.1</a:t>
                       </a:r>
                     </a:p>
                   </a:txBody>
@@ -5350,7 +5350,7 @@
                           </a:solidFill>
                           <a:latin typeface="Calibri"/>
                         </a:rPr>
-                        <a:t>0.7</a:t>
+                        <a:t>0.1</a:t>
                       </a:r>
                     </a:p>
                   </a:txBody>
@@ -5421,7 +5421,7 @@
                           </a:solidFill>
                           <a:latin typeface="Calibri"/>
                         </a:rPr>
-                        <a:t>8.9</a:t>
+                        <a:t>0.5</a:t>
                       </a:r>
                     </a:p>
                   </a:txBody>
@@ -5444,7 +5444,7 @@
                           </a:solidFill>
                           <a:latin typeface="Calibri"/>
                         </a:rPr>
-                        <a:t>10.1</a:t>
+                        <a:t>0.4</a:t>
                       </a:r>
                     </a:p>
                   </a:txBody>
@@ -5515,7 +5515,7 @@
                           </a:solidFill>
                           <a:latin typeface="Calibri"/>
                         </a:rPr>
-                        <a:t>2.3</a:t>
+                        <a:t>0.1</a:t>
                       </a:r>
                     </a:p>
                   </a:txBody>
@@ -5538,7 +5538,7 @@
                           </a:solidFill>
                           <a:latin typeface="Calibri"/>
                         </a:rPr>
-                        <a:t>1.2</a:t>
+                        <a:t>0.1</a:t>
                       </a:r>
                     </a:p>
                   </a:txBody>
@@ -5872,7 +5872,7 @@
                 </a:solidFill>
                 <a:latin typeface="Calibri"/>
               </a:rPr>
-              <a:t>The deep model matches the light model (MAE 34.8 s vs 33.6 s) yet uses ~30× the CPU. Accuracy alone cannot choose a model.</a:t>
+              <a:t>The deep model matches the light model (MAE 151.1 s vs 140.8 s) yet uses ~30× the CPU. Accuracy alone cannot choose a model.</a:t>
             </a:r>
           </a:p>
         </p:txBody>
@@ -10351,7 +10351,7 @@
                           </a:solidFill>
                           <a:latin typeface="Calibri"/>
                         </a:rPr>
-                        <a:t>194.4</a:t>
+                        <a:t>191.0</a:t>
                       </a:r>
                     </a:p>
                   </a:txBody>
@@ -10374,7 +10374,7 @@
                           </a:solidFill>
                           <a:latin typeface="Calibri"/>
                         </a:rPr>
-                        <a:t>263.1</a:t>
+                        <a:t>270.7</a:t>
                       </a:r>
                     </a:p>
                   </a:txBody>
@@ -10397,7 +10397,7 @@
                           </a:solidFill>
                           <a:latin typeface="Calibri"/>
                         </a:rPr>
-                        <a:t>0.9766</a:t>
+                        <a:t>0.9082</a:t>
                       </a:r>
                     </a:p>
                   </a:txBody>
@@ -10445,7 +10445,7 @@
                           </a:solidFill>
                           <a:latin typeface="Calibri"/>
                         </a:rPr>
-                        <a:t>33.6</a:t>
+                        <a:t>140.8</a:t>
                       </a:r>
                     </a:p>
                   </a:txBody>
@@ -10468,7 +10468,7 @@
                           </a:solidFill>
                           <a:latin typeface="Calibri"/>
                         </a:rPr>
-                        <a:t>50.0</a:t>
+                        <a:t>255.7</a:t>
                       </a:r>
                     </a:p>
                   </a:txBody>
@@ -10491,7 +10491,7 @@
                           </a:solidFill>
                           <a:latin typeface="Calibri"/>
                         </a:rPr>
-                        <a:t>0.9992</a:t>
+                        <a:t>0.9181</a:t>
                       </a:r>
                     </a:p>
                   </a:txBody>
@@ -10539,7 +10539,7 @@
                           </a:solidFill>
                           <a:latin typeface="Calibri"/>
                         </a:rPr>
-                        <a:t>34.8</a:t>
+                        <a:t>151.1</a:t>
                       </a:r>
                     </a:p>
                   </a:txBody>
@@ -10562,7 +10562,7 @@
                           </a:solidFill>
                           <a:latin typeface="Calibri"/>
                         </a:rPr>
-                        <a:t>45.0</a:t>
+                        <a:t>245.7</a:t>
                       </a:r>
                     </a:p>
                   </a:txBody>
@@ -10585,7 +10585,7 @@
                           </a:solidFill>
                           <a:latin typeface="Calibri"/>
                         </a:rPr>
-                        <a:t>0.9993</a:t>
+                        <a:t>0.9243</a:t>
                       </a:r>
                     </a:p>
                   </a:txBody>
@@ -10680,7 +10680,7 @@
                 </a:solidFill>
                 <a:latin typeface="Calibri"/>
               </a:rPr>
-              <a:t>MAE 33.6 s vs 34.8 s — 1.2 s apart</a:t>
+              <a:t>MAE 140.8 s vs 151.1 s — 10.3 s apart</a:t>
             </a:r>
           </a:p>
           <a:p>
@@ -10718,7 +10718,7 @@
                 </a:solidFill>
                 <a:latin typeface="Calibri"/>
               </a:rPr>
-              <a:t>•  Traditional linear regression is not expressive enough for ETA (MAE 194 s)</a:t>
+              <a:t>•  Traditional linear regression is not expressive enough for ETA (MAE 191 s)</a:t>
             </a:r>
           </a:p>
           <a:p>
@@ -10948,7 +10948,7 @@
                 </a:solidFill>
                 <a:latin typeface="Calibri"/>
               </a:rPr>
-              <a:t>•  gradient_boosting uses 1.5% — well within limits</a:t>
+              <a:t>•  gradient_boosting uses 1.2% — well within limits</a:t>
             </a:r>
           </a:p>
           <a:p>

</xml_diff>